<commit_message>
Brand deck v1.2: fix cover tagline, lockup overflow, italic examples, frame overflow, hero headline
</commit_message>
<xml_diff>
--- a/brand/BoothFunnel-Brand-Book-v1.pptx
+++ b/brand/BoothFunnel-Brand-Book-v1.pptx
@@ -2529,7 +2529,35 @@
                 <a:ea typeface="Helvetica Neue" pitchFamily="34" charset="-122"/>
                 <a:cs typeface="Helvetica Neue" pitchFamily="34" charset="-120"/>
               </a:rPr>
-              <a:t>Photobooths that pay for themselves.</a:t>
+              <a:t>A guest list, </a:t>
+            </a:r>
+            <a:pPr algn="ctr" indent="0" marL="0">
+              <a:buNone/>
+            </a:pPr>
+            <a:r>
+              <a:rPr lang="en-US" sz="1700" i="1" dirty="0">
+                <a:solidFill>
+                  <a:srgbClr val="B33A2A"/>
+                </a:solidFill>
+                <a:latin typeface="Georgia" pitchFamily="34" charset="0"/>
+                <a:ea typeface="Georgia" pitchFamily="34" charset="-122"/>
+                <a:cs typeface="Georgia" pitchFamily="34" charset="-120"/>
+              </a:rPr>
+              <a:t>disguised as a photobooth</a:t>
+            </a:r>
+            <a:pPr algn="ctr" indent="0" marL="0">
+              <a:buNone/>
+            </a:pPr>
+            <a:r>
+              <a:rPr lang="en-US" sz="1700" dirty="0">
+                <a:solidFill>
+                  <a:srgbClr val="1A1612"/>
+                </a:solidFill>
+                <a:latin typeface="Helvetica Neue" pitchFamily="34" charset="0"/>
+                <a:ea typeface="Helvetica Neue" pitchFamily="34" charset="-122"/>
+                <a:cs typeface="Helvetica Neue" pitchFamily="34" charset="-120"/>
+              </a:rPr>
+              <a:t>.</a:t>
             </a:r>
             <a:endParaRPr lang="en-US" sz="1700" dirty="0"/>
           </a:p>
@@ -5442,8 +5470,8 @@
         </p:nvSpPr>
         <p:spPr>
           <a:xfrm>
-            <a:off x="777240" y="2971800"/>
-            <a:ext cx="10607040" cy="640080"/>
+            <a:off x="777240" y="2907792"/>
+            <a:ext cx="10607040" cy="566928"/>
           </a:xfrm>
           <a:prstGeom prst="rect">
             <a:avLst/>
@@ -5467,7 +5495,7 @@
                 <a:ea typeface="Helvetica Neue" pitchFamily="34" charset="-122"/>
                 <a:cs typeface="Helvetica Neue" pitchFamily="34" charset="-120"/>
               </a:rPr>
-              <a:t>Photobooths that </a:t>
+              <a:t>A guest list, </a:t>
             </a:r>
             <a:pPr indent="0" marL="0">
               <a:buNone/>
@@ -5481,7 +5509,7 @@
                 <a:ea typeface="Georgia" pitchFamily="34" charset="-122"/>
                 <a:cs typeface="Georgia" pitchFamily="34" charset="-120"/>
               </a:rPr>
-              <a:t>pay for themselves</a:t>
+              <a:t>disguised as a photobooth</a:t>
             </a:r>
             <a:pPr indent="0" marL="0">
               <a:buNone/>
@@ -5509,7 +5537,7 @@
         </p:nvSpPr>
         <p:spPr>
           <a:xfrm>
-            <a:off x="777240" y="3520440"/>
+            <a:off x="777240" y="3493008"/>
             <a:ext cx="3657600" cy="182880"/>
           </a:xfrm>
           <a:prstGeom prst="rect">
@@ -5573,8 +5601,8 @@
         </p:nvSpPr>
         <p:spPr>
           <a:xfrm>
-            <a:off x="777240" y="4160520"/>
-            <a:ext cx="10607040" cy="640080"/>
+            <a:off x="777240" y="4096512"/>
+            <a:ext cx="10607040" cy="566928"/>
           </a:xfrm>
           <a:prstGeom prst="rect">
             <a:avLst/>
@@ -5598,7 +5626,7 @@
                 <a:ea typeface="Helvetica Neue" pitchFamily="34" charset="-122"/>
                 <a:cs typeface="Helvetica Neue" pitchFamily="34" charset="-120"/>
               </a:rPr>
-              <a:t>From box to revenue </a:t>
+              <a:t>From box to </a:t>
             </a:r>
             <a:pPr indent="0" marL="0">
               <a:buNone/>
@@ -5612,7 +5640,7 @@
                 <a:ea typeface="Georgia" pitchFamily="34" charset="-122"/>
                 <a:cs typeface="Georgia" pitchFamily="34" charset="-120"/>
               </a:rPr>
-              <a:t>in three moves</a:t>
+              <a:t>first contact</a:t>
             </a:r>
             <a:pPr indent="0" marL="0">
               <a:buNone/>
@@ -5626,7 +5654,7 @@
                 <a:ea typeface="Helvetica Neue" pitchFamily="34" charset="-122"/>
                 <a:cs typeface="Helvetica Neue" pitchFamily="34" charset="-120"/>
               </a:rPr>
-              <a:t>.</a:t>
+              <a:t>, in three moves.</a:t>
             </a:r>
             <a:endParaRPr lang="en-US" sz="2600" dirty="0"/>
           </a:p>
@@ -5640,7 +5668,7 @@
         </p:nvSpPr>
         <p:spPr>
           <a:xfrm>
-            <a:off x="777240" y="4709160"/>
+            <a:off x="777240" y="4681728"/>
             <a:ext cx="3657600" cy="182880"/>
           </a:xfrm>
           <a:prstGeom prst="rect">
@@ -5704,8 +5732,8 @@
         </p:nvSpPr>
         <p:spPr>
           <a:xfrm>
-            <a:off x="777240" y="5349240"/>
-            <a:ext cx="10607040" cy="640080"/>
+            <a:off x="777240" y="5285232"/>
+            <a:ext cx="10607040" cy="566928"/>
           </a:xfrm>
           <a:prstGeom prst="rect">
             <a:avLst/>
@@ -5729,7 +5757,7 @@
                 <a:ea typeface="Helvetica Neue" pitchFamily="34" charset="-122"/>
                 <a:cs typeface="Helvetica Neue" pitchFamily="34" charset="-120"/>
               </a:rPr>
-              <a:t>Your customers already take photos. </a:t>
+              <a:t>Branded photos. </a:t>
             </a:r>
             <a:pPr indent="0" marL="0">
               <a:buNone/>
@@ -5743,7 +5771,7 @@
                 <a:ea typeface="Georgia" pitchFamily="34" charset="-122"/>
                 <a:cs typeface="Georgia" pitchFamily="34" charset="-120"/>
               </a:rPr>
-              <a:t>None of them are branded yours</a:t>
+              <a:t>Real emails</a:t>
             </a:r>
             <a:pPr indent="0" marL="0">
               <a:buNone/>
@@ -5771,7 +5799,7 @@
         </p:nvSpPr>
         <p:spPr>
           <a:xfrm>
-            <a:off x="777240" y="5897880"/>
+            <a:off x="777240" y="5870448"/>
             <a:ext cx="3657600" cy="182880"/>
           </a:xfrm>
           <a:prstGeom prst="rect">
@@ -6024,7 +6052,7 @@
         <p:spPr>
           <a:xfrm>
             <a:off x="548640" y="2011680"/>
-            <a:ext cx="3657600" cy="4114800"/>
+            <a:ext cx="3657600" cy="3657600"/>
           </a:xfrm>
           <a:prstGeom prst="rect">
             <a:avLst/>
@@ -6056,7 +6084,7 @@
         <p:spPr>
           <a:xfrm>
             <a:off x="777240" y="2240280"/>
-            <a:ext cx="3200400" cy="3200400"/>
+            <a:ext cx="3200400" cy="2743200"/>
           </a:xfrm>
           <a:prstGeom prst="rect">
             <a:avLst/>
@@ -6080,7 +6108,7 @@
         </p:nvSpPr>
         <p:spPr>
           <a:xfrm>
-            <a:off x="777240" y="5532120"/>
+            <a:off x="777240" y="5120640"/>
             <a:ext cx="3200400" cy="365760"/>
           </a:xfrm>
           <a:prstGeom prst="rect">
@@ -6119,7 +6147,7 @@
         </p:nvSpPr>
         <p:spPr>
           <a:xfrm>
-            <a:off x="548640" y="6309360"/>
+            <a:off x="548640" y="5806440"/>
             <a:ext cx="3657600" cy="274320"/>
           </a:xfrm>
           <a:prstGeom prst="rect">
@@ -6159,7 +6187,7 @@
         <p:spPr>
           <a:xfrm>
             <a:off x="4343400" y="2011680"/>
-            <a:ext cx="3657600" cy="4114800"/>
+            <a:ext cx="3657600" cy="3657600"/>
           </a:xfrm>
           <a:prstGeom prst="rect">
             <a:avLst/>
@@ -6191,7 +6219,7 @@
         <p:spPr>
           <a:xfrm>
             <a:off x="4572000" y="2240280"/>
-            <a:ext cx="3200400" cy="3200400"/>
+            <a:ext cx="3200400" cy="2743200"/>
           </a:xfrm>
           <a:prstGeom prst="rect">
             <a:avLst/>
@@ -6215,7 +6243,7 @@
         </p:nvSpPr>
         <p:spPr>
           <a:xfrm>
-            <a:off x="4572000" y="5532120"/>
+            <a:off x="4572000" y="5120640"/>
             <a:ext cx="3200400" cy="365760"/>
           </a:xfrm>
           <a:prstGeom prst="rect">
@@ -6254,7 +6282,7 @@
         </p:nvSpPr>
         <p:spPr>
           <a:xfrm>
-            <a:off x="4343400" y="6309360"/>
+            <a:off x="4343400" y="5806440"/>
             <a:ext cx="3657600" cy="274320"/>
           </a:xfrm>
           <a:prstGeom prst="rect">
@@ -6294,7 +6322,7 @@
         <p:spPr>
           <a:xfrm>
             <a:off x="8138160" y="2011680"/>
-            <a:ext cx="3657600" cy="4114800"/>
+            <a:ext cx="3657600" cy="3657600"/>
           </a:xfrm>
           <a:prstGeom prst="rect">
             <a:avLst/>
@@ -6326,7 +6354,7 @@
         <p:spPr>
           <a:xfrm>
             <a:off x="8366760" y="2240280"/>
-            <a:ext cx="3200400" cy="3200400"/>
+            <a:ext cx="3200400" cy="2743200"/>
           </a:xfrm>
           <a:prstGeom prst="rect">
             <a:avLst/>
@@ -6350,7 +6378,7 @@
         </p:nvSpPr>
         <p:spPr>
           <a:xfrm>
-            <a:off x="8366760" y="5532120"/>
+            <a:off x="8366760" y="5120640"/>
             <a:ext cx="3200400" cy="365760"/>
           </a:xfrm>
           <a:prstGeom prst="rect">
@@ -6389,7 +6417,7 @@
         </p:nvSpPr>
         <p:spPr>
           <a:xfrm>
-            <a:off x="8138160" y="6309360"/>
+            <a:off x="8138160" y="5806440"/>
             <a:ext cx="3657600" cy="274320"/>
           </a:xfrm>
           <a:prstGeom prst="rect">
@@ -6422,32 +6450,7 @@
       </p:sp>
       <p:sp>
         <p:nvSpPr>
-          <p:cNvPr id="17" name="Shape 15"/>
-          <p:cNvSpPr/>
-          <p:nvPr/>
-        </p:nvSpPr>
-        <p:spPr>
-          <a:xfrm>
-            <a:off x="548640" y="6400800"/>
-            <a:ext cx="11064240" cy="0"/>
-          </a:xfrm>
-          <a:prstGeom prst="line">
-            <a:avLst/>
-          </a:prstGeom>
-          <a:noFill/>
-          <a:ln w="6350">
-            <a:solidFill>
-              <a:srgbClr val="C9A063">
-                <a:alpha val="50000"/>
-              </a:srgbClr>
-            </a:solidFill>
-            <a:prstDash val="solid"/>
-          </a:ln>
-        </p:spPr>
-      </p:sp>
-      <p:sp>
-        <p:nvSpPr>
-          <p:cNvPr id="18" name="Text 16"/>
+          <p:cNvPr id="17" name="Text 15"/>
           <p:cNvSpPr/>
           <p:nvPr/>
         </p:nvSpPr>
@@ -6486,7 +6489,7 @@
       </p:sp>
       <p:sp>
         <p:nvSpPr>
-          <p:cNvPr id="19" name="Text 17"/>
+          <p:cNvPr id="18" name="Text 16"/>
           <p:cNvSpPr/>
           <p:nvPr/>
         </p:nvSpPr>
@@ -8097,23 +8100,23 @@
         <p:spPr>
           <a:xfrm>
             <a:off x="914400" y="3657600"/>
-            <a:ext cx="5943600" cy="1280160"/>
-          </a:xfrm>
-          <a:prstGeom prst="rect">
-            <a:avLst/>
-          </a:prstGeom>
-          <a:noFill/>
-          <a:ln/>
-        </p:spPr>
-        <p:txBody>
-          <a:bodyPr wrap="square" lIns="0" tIns="0" rIns="0" bIns="0" rtlCol="0" anchor="ctr"/>
-          <a:lstStyle/>
-          <a:p>
-            <a:pPr indent="0" marL="0">
-              <a:buNone/>
-            </a:pPr>
-            <a:r>
-              <a:rPr lang="en-US" sz="3800" spc="-100" kern="0" dirty="0">
+            <a:ext cx="5943600" cy="1371600"/>
+          </a:xfrm>
+          <a:prstGeom prst="rect">
+            <a:avLst/>
+          </a:prstGeom>
+          <a:noFill/>
+          <a:ln/>
+        </p:spPr>
+        <p:txBody>
+          <a:bodyPr wrap="square" lIns="0" tIns="0" rIns="0" bIns="0" rtlCol="0" anchor="ctr"/>
+          <a:lstStyle/>
+          <a:p>
+            <a:pPr indent="0" marL="0">
+              <a:buNone/>
+            </a:pPr>
+            <a:r>
+              <a:rPr lang="en-US" sz="3400" spc="-100" kern="0" dirty="0">
                 <a:solidFill>
                   <a:srgbClr val="1A1612"/>
                 </a:solidFill>
@@ -8121,13 +8124,13 @@
                 <a:ea typeface="Helvetica Neue" pitchFamily="34" charset="-122"/>
                 <a:cs typeface="Helvetica Neue" pitchFamily="34" charset="-120"/>
               </a:rPr>
-              <a:t>Photobooths that </a:t>
-            </a:r>
-            <a:pPr indent="0" marL="0">
-              <a:buNone/>
-            </a:pPr>
-            <a:r>
-              <a:rPr lang="en-US" sz="3800" i="1" spc="-50" kern="0" dirty="0">
+              <a:t>A guest list, </a:t>
+            </a:r>
+            <a:pPr indent="0" marL="0">
+              <a:buNone/>
+            </a:pPr>
+            <a:r>
+              <a:rPr lang="en-US" sz="3400" i="1" spc="-50" kern="0" dirty="0">
                 <a:solidFill>
                   <a:srgbClr val="B33A2A"/>
                 </a:solidFill>
@@ -8135,13 +8138,13 @@
                 <a:ea typeface="Georgia" pitchFamily="34" charset="-122"/>
                 <a:cs typeface="Georgia" pitchFamily="34" charset="-120"/>
               </a:rPr>
-              <a:t>pay for themselves</a:t>
-            </a:r>
-            <a:pPr indent="0" marL="0">
-              <a:buNone/>
-            </a:pPr>
-            <a:r>
-              <a:rPr lang="en-US" sz="3800" dirty="0">
+              <a:t>disguised as a photobooth</a:t>
+            </a:r>
+            <a:pPr indent="0" marL="0">
+              <a:buNone/>
+            </a:pPr>
+            <a:r>
+              <a:rPr lang="en-US" sz="3400" dirty="0">
                 <a:solidFill>
                   <a:srgbClr val="1A1612"/>
                 </a:solidFill>
@@ -8151,7 +8154,7 @@
               </a:rPr>
               <a:t>.</a:t>
             </a:r>
-            <a:endParaRPr lang="en-US" sz="3800" dirty="0"/>
+            <a:endParaRPr lang="en-US" sz="3400" dirty="0"/>
           </a:p>
         </p:txBody>
       </p:sp>
@@ -8164,7 +8167,7 @@
         <p:spPr>
           <a:xfrm>
             <a:off x="914400" y="5074920"/>
-            <a:ext cx="5943600" cy="731520"/>
+            <a:ext cx="5943600" cy="822960"/>
           </a:xfrm>
           <a:prstGeom prst="rect">
             <a:avLst/>
@@ -8178,12 +8181,12 @@
           <a:p>
             <a:pPr indent="0" marL="0">
               <a:lnSpc>
-                <a:spcPts val="2000"/>
+                <a:spcPts val="1800"/>
               </a:lnSpc>
               <a:buNone/>
             </a:pPr>
             <a:r>
-              <a:rPr lang="en-US" sz="1300" dirty="0">
+              <a:rPr lang="en-US" sz="1200" dirty="0">
                 <a:solidFill>
                   <a:srgbClr val="5A4A38"/>
                 </a:solidFill>
@@ -8191,9 +8194,9 @@
                 <a:ea typeface="Helvetica Neue" pitchFamily="34" charset="-122"/>
                 <a:cs typeface="Helvetica Neue" pitchFamily="34" charset="-120"/>
               </a:rPr>
-              <a:t>Branded social booths for bars, restaurants, and event venues — built so every guest becomes your next ad.</a:t>
-            </a:r>
-            <a:endParaRPr lang="en-US" sz="1300" dirty="0"/>
+              <a:t>Every guest who steps in front of the booth gives you their email. They walk away with a branded shot built for sharing. You walk away with a contact list.</a:t>
+            </a:r>
+            <a:endParaRPr lang="en-US" sz="1200" dirty="0"/>
           </a:p>
         </p:txBody>
       </p:sp>
@@ -12772,8 +12775,8 @@
         </p:nvSpPr>
         <p:spPr>
           <a:xfrm>
-            <a:off x="3017520" y="3108960"/>
-            <a:ext cx="1554480" cy="1554480"/>
+            <a:off x="2560320" y="3383280"/>
+            <a:ext cx="1280160" cy="1280160"/>
           </a:xfrm>
           <a:prstGeom prst="ellipse">
             <a:avLst/>
@@ -12799,8 +12802,8 @@
         </p:nvSpPr>
         <p:spPr>
           <a:xfrm>
-            <a:off x="3017520" y="3171139"/>
-            <a:ext cx="1554480" cy="1554480"/>
+            <a:off x="2560320" y="3434486"/>
+            <a:ext cx="1280160" cy="1280160"/>
           </a:xfrm>
           <a:prstGeom prst="rect">
             <a:avLst/>
@@ -12816,7 +12819,7 @@
               <a:buNone/>
             </a:pPr>
             <a:r>
-              <a:rPr lang="en-US" sz="8500" i="1" dirty="0">
+              <a:rPr lang="en-US" sz="7000" i="1" dirty="0">
                 <a:solidFill>
                   <a:srgbClr val="1A1612"/>
                 </a:solidFill>
@@ -12826,7 +12829,7 @@
               </a:rPr>
               <a:t>bf</a:t>
             </a:r>
-            <a:endParaRPr lang="en-US" sz="8500" dirty="0"/>
+            <a:endParaRPr lang="en-US" sz="7000" dirty="0"/>
           </a:p>
         </p:txBody>
       </p:sp>
@@ -12838,8 +12841,8 @@
         </p:nvSpPr>
         <p:spPr>
           <a:xfrm>
-            <a:off x="4937760" y="3291840"/>
-            <a:ext cx="0" cy="1188720"/>
+            <a:off x="4114800" y="3520440"/>
+            <a:ext cx="0" cy="914400"/>
           </a:xfrm>
           <a:prstGeom prst="line">
             <a:avLst/>
@@ -12861,24 +12864,24 @@
         </p:nvSpPr>
         <p:spPr>
           <a:xfrm>
-            <a:off x="5212080" y="3520440"/>
-            <a:ext cx="10972800" cy="1645920"/>
-          </a:xfrm>
-          <a:prstGeom prst="rect">
-            <a:avLst/>
-          </a:prstGeom>
-          <a:noFill/>
-          <a:ln/>
-        </p:spPr>
-        <p:txBody>
-          <a:bodyPr wrap="square" lIns="0" tIns="0" rIns="0" bIns="0" rtlCol="0" anchor="ctr"/>
-          <a:lstStyle/>
-          <a:p>
-            <a:pPr indent="0" marL="0">
-              <a:buNone/>
-            </a:pPr>
-            <a:r>
-              <a:rPr lang="en-US" sz="9000" spc="-200" kern="0" dirty="0">
+            <a:off x="4434840" y="3657600"/>
+            <a:ext cx="10972800" cy="1280160"/>
+          </a:xfrm>
+          <a:prstGeom prst="rect">
+            <a:avLst/>
+          </a:prstGeom>
+          <a:noFill/>
+          <a:ln/>
+        </p:spPr>
+        <p:txBody>
+          <a:bodyPr wrap="square" lIns="0" tIns="0" rIns="0" bIns="0" rtlCol="0" anchor="ctr"/>
+          <a:lstStyle/>
+          <a:p>
+            <a:pPr indent="0" marL="0">
+              <a:buNone/>
+            </a:pPr>
+            <a:r>
+              <a:rPr lang="en-US" sz="7000" spc="-200" kern="0" dirty="0">
                 <a:solidFill>
                   <a:srgbClr val="1A1612"/>
                 </a:solidFill>
@@ -12892,7 +12895,7 @@
               <a:buNone/>
             </a:pPr>
             <a:r>
-              <a:rPr lang="en-US" sz="9000" i="1" spc="-100" kern="0" dirty="0">
+              <a:rPr lang="en-US" sz="7000" i="1" spc="-100" kern="0" dirty="0">
                 <a:solidFill>
                   <a:srgbClr val="B33A2A"/>
                 </a:solidFill>
@@ -12902,7 +12905,7 @@
               </a:rPr>
               <a:t>funnel</a:t>
             </a:r>
-            <a:endParaRPr lang="en-US" sz="9000" dirty="0"/>
+            <a:endParaRPr lang="en-US" sz="7000" dirty="0"/>
           </a:p>
         </p:txBody>
       </p:sp>

</xml_diff>